<commit_message>
docs: add the usage guide slides as PDF in three languages
Export the how-to-advance-tasks-efficiently slides to PDF for
Chinese, English, and Japanese, and include the updated English and
Japanese slide sources.

Co-Authored-By: Claude Fable 5 <noreply@anthropic.com>
Claude-Session: https://claude.ai/code/session_01SNm5xzah9JHTZw49BfGXeA
</commit_message>
<xml_diff>
--- a/docs/how-to-advance-tasks-efficiently-en.pptx
+++ b/docs/how-to-advance-tasks-efficiently-en.pptx
@@ -3779,7 +3779,7 @@
       </p:sp>
     </p:spTree>
     <p:custDataLst>
-      <p:tags r:id="rId4"/>
+      <p:tags r:id="rId3"/>
     </p:custDataLst>
   </p:cSld>
   <p:clrMapOvr>
@@ -3929,65 +3929,65 @@
           <a:bodyPr/>
           <a:p>
             <a:r>
-              <a:rPr lang="en-US" altLang="en-US" sz="2800"/>
+              <a:rPr lang="en-US" altLang="en-US" sz="2400"/>
               <a:t>Depending on task complexity, a task card consists of one or more Markdown files.</a:t>
             </a:r>
-            <a:endParaRPr lang="en-US" altLang="en-US" sz="2800"/>
-          </a:p>
-          <a:p>
-            <a:r>
-              <a:rPr lang="en-US" altLang="en-US" sz="2800"/>
+            <a:endParaRPr lang="en-US" altLang="en-US" sz="2400"/>
+          </a:p>
+          <a:p>
+            <a:r>
+              <a:rPr lang="en-US" altLang="en-US" sz="2400"/>
               <a:t>All task cards are stored under the project's ./kanban/ directory.</a:t>
             </a:r>
-            <a:endParaRPr lang="en-US" altLang="en-US" sz="2800"/>
-          </a:p>
-          <a:p>
-            <a:r>
-              <a:rPr lang="en-US" altLang="en-US" sz="2800">
+            <a:endParaRPr lang="en-US" altLang="en-US" sz="2400"/>
+          </a:p>
+          <a:p>
+            <a:r>
+              <a:rPr lang="en-US" altLang="en-US" sz="2400">
                 <a:sym typeface="+mn-ea"/>
               </a:rPr>
               <a:t>The Markdown contains everything needed to complete the task:</a:t>
             </a:r>
-            <a:endParaRPr lang="en-US" altLang="en-US" sz="2800">
+            <a:endParaRPr lang="en-US" altLang="en-US" sz="2400">
               <a:sym typeface="+mn-ea"/>
             </a:endParaRPr>
           </a:p>
           <a:p>
             <a:pPr lvl="1"/>
             <a:r>
-              <a:rPr lang="en-US" altLang="en-US" sz="2485">
+              <a:rPr lang="en-US" altLang="en-US" sz="2400">
                 <a:sym typeface="+mn-ea"/>
               </a:rPr>
               <a:t>Task description</a:t>
             </a:r>
-            <a:endParaRPr lang="en-US" altLang="en-US" sz="2485">
+            <a:endParaRPr lang="en-US" altLang="en-US" sz="2400">
               <a:sym typeface="+mn-ea"/>
             </a:endParaRPr>
           </a:p>
           <a:p>
             <a:pPr lvl="1"/>
             <a:r>
-              <a:rPr lang="en-US" altLang="en-US" sz="2485">
+              <a:rPr lang="en-US" altLang="en-US" sz="2400">
                 <a:sym typeface="+mn-ea"/>
               </a:rPr>
               <a:t>Task checklist</a:t>
             </a:r>
-            <a:endParaRPr lang="en-US" altLang="en-US" sz="2485">
+            <a:endParaRPr lang="en-US" altLang="en-US" sz="2400">
               <a:sym typeface="+mn-ea"/>
             </a:endParaRPr>
           </a:p>
           <a:p>
             <a:pPr lvl="1"/>
             <a:r>
-              <a:rPr lang="en-US" altLang="en-US" sz="2485">
+              <a:rPr lang="en-US" altLang="en-US" sz="2400">
                 <a:sym typeface="+mn-ea"/>
               </a:rPr>
               <a:t>Acceptance checklist</a:t>
             </a:r>
-            <a:endParaRPr lang="en-US" altLang="en-US" sz="2485"/>
-          </a:p>
-          <a:p>
-            <a:endParaRPr lang="en-US" altLang="en-US" sz="2800"/>
+            <a:endParaRPr lang="en-US" altLang="en-US" sz="2400"/>
+          </a:p>
+          <a:p>
+            <a:endParaRPr lang="en-US" altLang="en-US" sz="2400"/>
           </a:p>
         </p:txBody>
       </p:sp>

</xml_diff>